<commit_message>
Fix PPTX: 16:9 aspect ratio + larger font sizes
- Slide size: 10x7.5 (4:3) -> 13.333x7.5 (16:9)
- Title: 22pt -> 28pt, Bullet: 14pt -> 18pt, Table: 10-11pt -> 13-14pt
- All textbox widths adjusted for widescreen layout

Co-Authored-By: Claude Opus 4.6 (1M context) <noreply@anthropic.com>
</commit_message>
<xml_diff>
--- a/docs/hanasaku_service_overview.pptx
+++ b/docs/hanasaku_service_overview.pptx
@@ -16,7 +16,7 @@
     <p:sldId id="264" r:id="rId15"/>
     <p:sldId id="265" r:id="rId16"/>
   </p:sldIdLst>
-  <p:sldSz cx="9144000" cy="6858000" type="screen4x3"/>
+  <p:sldSz cx="12191695" cy="6858000" type="screen4x3"/>
   <p:notesSz cx="6858000" cy="9144000"/>
   <p:defaultTextStyle>
     <a:defPPr>
@@ -3113,8 +3113,8 @@
         </p:nvSpPr>
         <p:spPr>
           <a:xfrm>
-            <a:off x="731520" y="1371600"/>
-            <a:ext cx="7680960" cy="1828800"/>
+            <a:off x="1097280" y="1371600"/>
+            <a:ext cx="10058400" cy="2286000"/>
           </a:xfrm>
           <a:prstGeom prst="rect">
             <a:avLst/>
@@ -3128,7 +3128,7 @@
           <a:lstStyle/>
           <a:p>
             <a:pPr algn="l">
-              <a:defRPr sz="3200" b="1">
+              <a:defRPr sz="4000" b="1">
                 <a:solidFill>
                   <a:srgbClr val="FFFFFF"/>
                 </a:solidFill>
@@ -3144,7 +3144,10 @@
           </a:p>
           <a:p>
             <a:pPr algn="l">
-              <a:defRPr sz="1600">
+              <a:spcBef>
+                <a:spcPts val="1200"/>
+              </a:spcBef>
+              <a:defRPr sz="2000">
                 <a:solidFill>
                   <a:srgbClr val="E8A0A8"/>
                 </a:solidFill>
@@ -3195,8 +3198,8 @@
         </p:nvSpPr>
         <p:spPr>
           <a:xfrm>
-            <a:off x="731520" y="2286000"/>
-            <a:ext cx="7680960" cy="1371600"/>
+            <a:off x="1097280" y="2286000"/>
+            <a:ext cx="10058400" cy="1828800"/>
           </a:xfrm>
           <a:prstGeom prst="rect">
             <a:avLst/>
@@ -3210,7 +3213,7 @@
           <a:lstStyle/>
           <a:p>
             <a:pPr algn="ctr">
-              <a:defRPr sz="2800" b="1">
+              <a:defRPr sz="3600" b="1">
                 <a:solidFill>
                   <a:srgbClr val="FFFFFF"/>
                 </a:solidFill>
@@ -3230,8 +3233,8 @@
         </p:nvSpPr>
         <p:spPr>
           <a:xfrm>
-            <a:off x="731520" y="3657600"/>
-            <a:ext cx="7680960" cy="2286000"/>
+            <a:off x="1097280" y="3657600"/>
+            <a:ext cx="10058400" cy="2743200"/>
           </a:xfrm>
           <a:prstGeom prst="rect">
             <a:avLst/>
@@ -3246,66 +3249,66 @@
           <a:p>
             <a:pPr algn="ctr">
               <a:spcAft>
-                <a:spcPts val="800"/>
+                <a:spcPts val="1200"/>
+              </a:spcAft>
+              <a:defRPr sz="1800">
+                <a:solidFill>
+                  <a:srgbClr val="E8A0A8"/>
+                </a:solidFill>
+              </a:defRPr>
+            </a:pPr>
+            <a:r>
+              <a:t>LP: https://mai-san447.github.io/hanasaku-career/</a:t>
+            </a:r>
+          </a:p>
+          <a:p>
+            <a:pPr algn="ctr">
+              <a:spcAft>
+                <a:spcPts val="1200"/>
+              </a:spcAft>
+              <a:defRPr sz="1800">
+                <a:solidFill>
+                  <a:srgbClr val="E8A0A8"/>
+                </a:solidFill>
+              </a:defRPr>
+            </a:pPr>
+            <a:r>
+              <a:t>無料相談予約: https://calendar.app.google/u8SkpMApaMfaRoSx6</a:t>
+            </a:r>
+          </a:p>
+          <a:p>
+            <a:pPr algn="ctr">
+              <a:spcAft>
+                <a:spcPts val="1200"/>
+              </a:spcAft>
+              <a:defRPr sz="1800">
+                <a:solidFill>
+                  <a:srgbClr val="E8A0A8"/>
+                </a:solidFill>
+              </a:defRPr>
+            </a:pPr>
+            <a:r>
+              <a:t>LINE公式: https://lin.ee/qURXYyS</a:t>
+            </a:r>
+          </a:p>
+          <a:p>
+            <a:pPr algn="ctr">
+              <a:spcAft>
+                <a:spcPts val="1200"/>
               </a:spcAft>
               <a:defRPr sz="1400">
                 <a:solidFill>
-                  <a:srgbClr val="E8A0A8"/>
-                </a:solidFill>
-              </a:defRPr>
-            </a:pPr>
-            <a:r>
-              <a:t>LP: https://mai-san447.github.io/hanasaku-career/</a:t>
-            </a:r>
+                  <a:srgbClr val="888888"/>
+                </a:solidFill>
+              </a:defRPr>
+            </a:pPr>
           </a:p>
           <a:p>
             <a:pPr algn="ctr">
               <a:spcAft>
-                <a:spcPts val="800"/>
+                <a:spcPts val="1200"/>
               </a:spcAft>
               <a:defRPr sz="1400">
-                <a:solidFill>
-                  <a:srgbClr val="E8A0A8"/>
-                </a:solidFill>
-              </a:defRPr>
-            </a:pPr>
-            <a:r>
-              <a:t>無料相談予約: https://calendar.app.google/u8SkpMApaMfaRoSx6</a:t>
-            </a:r>
-          </a:p>
-          <a:p>
-            <a:pPr algn="ctr">
-              <a:spcAft>
-                <a:spcPts val="800"/>
-              </a:spcAft>
-              <a:defRPr sz="1400">
-                <a:solidFill>
-                  <a:srgbClr val="E8A0A8"/>
-                </a:solidFill>
-              </a:defRPr>
-            </a:pPr>
-            <a:r>
-              <a:t>LINE公式: https://lin.ee/qURXYyS</a:t>
-            </a:r>
-          </a:p>
-          <a:p>
-            <a:pPr algn="ctr">
-              <a:spcAft>
-                <a:spcPts val="800"/>
-              </a:spcAft>
-              <a:defRPr sz="1100">
-                <a:solidFill>
-                  <a:srgbClr val="888888"/>
-                </a:solidFill>
-              </a:defRPr>
-            </a:pPr>
-          </a:p>
-          <a:p>
-            <a:pPr algn="ctr">
-              <a:spcAft>
-                <a:spcPts val="800"/>
-              </a:spcAft>
-              <a:defRPr sz="1100">
                 <a:solidFill>
                   <a:srgbClr val="888888"/>
                 </a:solidFill>
@@ -3344,7 +3347,7 @@
         <p:spPr>
           <a:xfrm>
             <a:off x="0" y="0"/>
-            <a:ext cx="9144000" cy="914400"/>
+            <a:ext cx="12191695" cy="1005840"/>
           </a:xfrm>
           <a:prstGeom prst="rect">
             <a:avLst/>
@@ -3358,7 +3361,7 @@
           <a:lstStyle/>
           <a:p>
             <a:pPr algn="l">
-              <a:defRPr sz="2200" b="1">
+              <a:defRPr sz="2800" b="1">
                 <a:solidFill>
                   <a:srgbClr val="5A2030"/>
                 </a:solidFill>
@@ -3378,8 +3381,8 @@
         </p:nvSpPr>
         <p:spPr>
           <a:xfrm>
-            <a:off x="457200" y="868680"/>
-            <a:ext cx="8229600" cy="27432"/>
+            <a:off x="731520" y="960120"/>
+            <a:ext cx="10698480" cy="27432"/>
           </a:xfrm>
           <a:prstGeom prst="rect">
             <a:avLst/>
@@ -3421,8 +3424,8 @@
         </p:nvSpPr>
         <p:spPr>
           <a:xfrm>
-            <a:off x="548640" y="1097280"/>
-            <a:ext cx="8046720" cy="5029200"/>
+            <a:off x="914400" y="1280160"/>
+            <a:ext cx="10332720" cy="5029200"/>
           </a:xfrm>
           <a:prstGeom prst="rect">
             <a:avLst/>
@@ -3437,9 +3440,9 @@
           <a:p>
             <a:pPr>
               <a:spcAft>
-                <a:spcPts val="600"/>
+                <a:spcPts val="800"/>
               </a:spcAft>
-              <a:defRPr sz="1400">
+              <a:defRPr sz="1800">
                 <a:solidFill>
                   <a:srgbClr val="333333"/>
                 </a:solidFill>
@@ -3452,9 +3455,9 @@
           <a:p>
             <a:pPr>
               <a:spcAft>
-                <a:spcPts val="600"/>
+                <a:spcPts val="800"/>
               </a:spcAft>
-              <a:defRPr sz="1400">
+              <a:defRPr sz="1800">
                 <a:solidFill>
                   <a:srgbClr val="333333"/>
                 </a:solidFill>
@@ -3467,9 +3470,9 @@
           <a:p>
             <a:pPr>
               <a:spcAft>
-                <a:spcPts val="600"/>
+                <a:spcPts val="800"/>
               </a:spcAft>
-              <a:defRPr sz="1400">
+              <a:defRPr sz="1800">
                 <a:solidFill>
                   <a:srgbClr val="333333"/>
                 </a:solidFill>
@@ -3479,9 +3482,9 @@
           <a:p>
             <a:pPr>
               <a:spcAft>
-                <a:spcPts val="600"/>
+                <a:spcPts val="800"/>
               </a:spcAft>
-              <a:defRPr sz="1400" b="1">
+              <a:defRPr sz="1800" b="1">
                 <a:solidFill>
                   <a:srgbClr val="5A2030"/>
                 </a:solidFill>
@@ -3494,9 +3497,9 @@
           <a:p>
             <a:pPr lvl="1">
               <a:spcAft>
-                <a:spcPts val="600"/>
+                <a:spcPts val="800"/>
               </a:spcAft>
-              <a:defRPr sz="1200">
+              <a:defRPr sz="1600">
                 <a:solidFill>
                   <a:srgbClr val="333333"/>
                 </a:solidFill>
@@ -3509,9 +3512,9 @@
           <a:p>
             <a:pPr lvl="1">
               <a:spcAft>
-                <a:spcPts val="600"/>
+                <a:spcPts val="800"/>
               </a:spcAft>
-              <a:defRPr sz="1200">
+              <a:defRPr sz="1600">
                 <a:solidFill>
                   <a:srgbClr val="333333"/>
                 </a:solidFill>
@@ -3524,9 +3527,9 @@
           <a:p>
             <a:pPr lvl="1">
               <a:spcAft>
-                <a:spcPts val="600"/>
+                <a:spcPts val="800"/>
               </a:spcAft>
-              <a:defRPr sz="1200">
+              <a:defRPr sz="1600">
                 <a:solidFill>
                   <a:srgbClr val="333333"/>
                 </a:solidFill>
@@ -3539,9 +3542,9 @@
           <a:p>
             <a:pPr>
               <a:spcAft>
-                <a:spcPts val="600"/>
+                <a:spcPts val="800"/>
               </a:spcAft>
-              <a:defRPr sz="1400">
+              <a:defRPr sz="1800">
                 <a:solidFill>
                   <a:srgbClr val="333333"/>
                 </a:solidFill>
@@ -3551,9 +3554,9 @@
           <a:p>
             <a:pPr>
               <a:spcAft>
-                <a:spcPts val="600"/>
+                <a:spcPts val="800"/>
               </a:spcAft>
-              <a:defRPr sz="1400" b="1">
+              <a:defRPr sz="1800" b="1">
                 <a:solidFill>
                   <a:srgbClr val="5A2030"/>
                 </a:solidFill>
@@ -3566,9 +3569,9 @@
           <a:p>
             <a:pPr lvl="1">
               <a:spcAft>
-                <a:spcPts val="600"/>
+                <a:spcPts val="800"/>
               </a:spcAft>
-              <a:defRPr sz="1200">
+              <a:defRPr sz="1600">
                 <a:solidFill>
                   <a:srgbClr val="333333"/>
                 </a:solidFill>
@@ -3581,9 +3584,9 @@
           <a:p>
             <a:pPr lvl="1">
               <a:spcAft>
-                <a:spcPts val="600"/>
+                <a:spcPts val="800"/>
               </a:spcAft>
-              <a:defRPr sz="1200">
+              <a:defRPr sz="1600">
                 <a:solidFill>
                   <a:srgbClr val="333333"/>
                 </a:solidFill>
@@ -3596,9 +3599,9 @@
           <a:p>
             <a:pPr lvl="1">
               <a:spcAft>
-                <a:spcPts val="600"/>
+                <a:spcPts val="800"/>
               </a:spcAft>
-              <a:defRPr sz="1200">
+              <a:defRPr sz="1600">
                 <a:solidFill>
                   <a:srgbClr val="333333"/>
                 </a:solidFill>
@@ -3637,7 +3640,7 @@
         <p:spPr>
           <a:xfrm>
             <a:off x="0" y="0"/>
-            <a:ext cx="9144000" cy="914400"/>
+            <a:ext cx="12191695" cy="1005840"/>
           </a:xfrm>
           <a:prstGeom prst="rect">
             <a:avLst/>
@@ -3651,7 +3654,7 @@
           <a:lstStyle/>
           <a:p>
             <a:pPr algn="l">
-              <a:defRPr sz="2200" b="1">
+              <a:defRPr sz="2800" b="1">
                 <a:solidFill>
                   <a:srgbClr val="5A2030"/>
                 </a:solidFill>
@@ -3671,8 +3674,8 @@
         </p:nvSpPr>
         <p:spPr>
           <a:xfrm>
-            <a:off x="457200" y="868680"/>
-            <a:ext cx="8229600" cy="27432"/>
+            <a:off x="731520" y="960120"/>
+            <a:ext cx="10698480" cy="27432"/>
           </a:xfrm>
           <a:prstGeom prst="rect">
             <a:avLst/>
@@ -3714,8 +3717,8 @@
         </p:nvSpPr>
         <p:spPr>
           <a:xfrm>
-            <a:off x="548640" y="1097280"/>
-            <a:ext cx="8046720" cy="5029200"/>
+            <a:off x="914400" y="1280160"/>
+            <a:ext cx="10332720" cy="5029200"/>
           </a:xfrm>
           <a:prstGeom prst="rect">
             <a:avLst/>
@@ -3730,9 +3733,9 @@
           <a:p>
             <a:pPr>
               <a:spcAft>
-                <a:spcPts val="600"/>
+                <a:spcPts val="800"/>
               </a:spcAft>
-              <a:defRPr sz="1400" b="1">
+              <a:defRPr sz="1800" b="1">
                 <a:solidFill>
                   <a:srgbClr val="5A2030"/>
                 </a:solidFill>
@@ -3745,9 +3748,9 @@
           <a:p>
             <a:pPr lvl="1">
               <a:spcAft>
-                <a:spcPts val="600"/>
+                <a:spcPts val="800"/>
               </a:spcAft>
-              <a:defRPr sz="1200">
+              <a:defRPr sz="1600">
                 <a:solidFill>
                   <a:srgbClr val="333333"/>
                 </a:solidFill>
@@ -3760,9 +3763,9 @@
           <a:p>
             <a:pPr lvl="1">
               <a:spcAft>
-                <a:spcPts val="600"/>
+                <a:spcPts val="800"/>
               </a:spcAft>
-              <a:defRPr sz="1200">
+              <a:defRPr sz="1600">
                 <a:solidFill>
                   <a:srgbClr val="333333"/>
                 </a:solidFill>
@@ -3775,9 +3778,9 @@
           <a:p>
             <a:pPr lvl="1">
               <a:spcAft>
-                <a:spcPts val="600"/>
+                <a:spcPts val="800"/>
               </a:spcAft>
-              <a:defRPr sz="1200">
+              <a:defRPr sz="1600">
                 <a:solidFill>
                   <a:srgbClr val="333333"/>
                 </a:solidFill>
@@ -3790,9 +3793,9 @@
           <a:p>
             <a:pPr lvl="1">
               <a:spcAft>
-                <a:spcPts val="600"/>
+                <a:spcPts val="800"/>
               </a:spcAft>
-              <a:defRPr sz="1200">
+              <a:defRPr sz="1600">
                 <a:solidFill>
                   <a:srgbClr val="333333"/>
                 </a:solidFill>
@@ -3805,9 +3808,9 @@
           <a:p>
             <a:pPr>
               <a:spcAft>
-                <a:spcPts val="600"/>
+                <a:spcPts val="800"/>
               </a:spcAft>
-              <a:defRPr sz="1400">
+              <a:defRPr sz="1800">
                 <a:solidFill>
                   <a:srgbClr val="333333"/>
                 </a:solidFill>
@@ -3817,9 +3820,9 @@
           <a:p>
             <a:pPr>
               <a:spcAft>
-                <a:spcPts val="600"/>
+                <a:spcPts val="800"/>
               </a:spcAft>
-              <a:defRPr sz="1400" b="1">
+              <a:defRPr sz="1800" b="1">
                 <a:solidFill>
                   <a:srgbClr val="5A2030"/>
                 </a:solidFill>
@@ -3832,9 +3835,9 @@
           <a:p>
             <a:pPr lvl="1">
               <a:spcAft>
-                <a:spcPts val="600"/>
+                <a:spcPts val="800"/>
               </a:spcAft>
-              <a:defRPr sz="1200">
+              <a:defRPr sz="1600">
                 <a:solidFill>
                   <a:srgbClr val="333333"/>
                 </a:solidFill>
@@ -3847,9 +3850,9 @@
           <a:p>
             <a:pPr lvl="1">
               <a:spcAft>
-                <a:spcPts val="600"/>
+                <a:spcPts val="800"/>
               </a:spcAft>
-              <a:defRPr sz="1200">
+              <a:defRPr sz="1600">
                 <a:solidFill>
                   <a:srgbClr val="333333"/>
                 </a:solidFill>
@@ -3862,9 +3865,9 @@
           <a:p>
             <a:pPr lvl="1">
               <a:spcAft>
-                <a:spcPts val="600"/>
+                <a:spcPts val="800"/>
               </a:spcAft>
-              <a:defRPr sz="1200">
+              <a:defRPr sz="1600">
                 <a:solidFill>
                   <a:srgbClr val="333333"/>
                 </a:solidFill>
@@ -3877,9 +3880,9 @@
           <a:p>
             <a:pPr>
               <a:spcAft>
-                <a:spcPts val="600"/>
+                <a:spcPts val="800"/>
               </a:spcAft>
-              <a:defRPr sz="1400">
+              <a:defRPr sz="1800">
                 <a:solidFill>
                   <a:srgbClr val="333333"/>
                 </a:solidFill>
@@ -3889,9 +3892,9 @@
           <a:p>
             <a:pPr>
               <a:spcAft>
-                <a:spcPts val="600"/>
+                <a:spcPts val="800"/>
               </a:spcAft>
-              <a:defRPr sz="1400" b="1">
+              <a:defRPr sz="1800" b="1">
                 <a:solidFill>
                   <a:srgbClr val="5A2030"/>
                 </a:solidFill>
@@ -3904,9 +3907,9 @@
           <a:p>
             <a:pPr lvl="1">
               <a:spcAft>
-                <a:spcPts val="600"/>
+                <a:spcPts val="800"/>
               </a:spcAft>
-              <a:defRPr sz="1200">
+              <a:defRPr sz="1600">
                 <a:solidFill>
                   <a:srgbClr val="333333"/>
                 </a:solidFill>
@@ -3919,9 +3922,9 @@
           <a:p>
             <a:pPr lvl="1">
               <a:spcAft>
-                <a:spcPts val="600"/>
+                <a:spcPts val="800"/>
               </a:spcAft>
-              <a:defRPr sz="1200">
+              <a:defRPr sz="1600">
                 <a:solidFill>
                   <a:srgbClr val="333333"/>
                 </a:solidFill>
@@ -3934,9 +3937,9 @@
           <a:p>
             <a:pPr lvl="1">
               <a:spcAft>
-                <a:spcPts val="600"/>
+                <a:spcPts val="800"/>
               </a:spcAft>
-              <a:defRPr sz="1200">
+              <a:defRPr sz="1600">
                 <a:solidFill>
                   <a:srgbClr val="333333"/>
                 </a:solidFill>
@@ -3975,7 +3978,7 @@
         <p:spPr>
           <a:xfrm>
             <a:off x="0" y="0"/>
-            <a:ext cx="9144000" cy="914400"/>
+            <a:ext cx="12191695" cy="1005840"/>
           </a:xfrm>
           <a:prstGeom prst="rect">
             <a:avLst/>
@@ -3989,7 +3992,7 @@
           <a:lstStyle/>
           <a:p>
             <a:pPr algn="l">
-              <a:defRPr sz="2200" b="1">
+              <a:defRPr sz="2800" b="1">
                 <a:solidFill>
                   <a:srgbClr val="5A2030"/>
                 </a:solidFill>
@@ -4009,8 +4012,8 @@
         </p:nvSpPr>
         <p:spPr>
           <a:xfrm>
-            <a:off x="457200" y="868680"/>
-            <a:ext cx="8229600" cy="27432"/>
+            <a:off x="731520" y="960120"/>
+            <a:ext cx="10698480" cy="27432"/>
           </a:xfrm>
           <a:prstGeom prst="rect">
             <a:avLst/>
@@ -4052,8 +4055,8 @@
         </p:nvSpPr>
         <p:spPr>
           <a:xfrm>
-            <a:off x="548640" y="1097280"/>
-            <a:ext cx="8046720" cy="5029200"/>
+            <a:off x="914400" y="1280160"/>
+            <a:ext cx="10332720" cy="5029200"/>
           </a:xfrm>
           <a:prstGeom prst="rect">
             <a:avLst/>
@@ -4068,9 +4071,9 @@
           <a:p>
             <a:pPr>
               <a:spcAft>
-                <a:spcPts val="600"/>
+                <a:spcPts val="800"/>
               </a:spcAft>
-              <a:defRPr sz="1400" b="1">
+              <a:defRPr sz="1800" b="1">
                 <a:solidFill>
                   <a:srgbClr val="5A2030"/>
                 </a:solidFill>
@@ -4083,9 +4086,9 @@
           <a:p>
             <a:pPr lvl="1">
               <a:spcAft>
-                <a:spcPts val="600"/>
+                <a:spcPts val="800"/>
               </a:spcAft>
-              <a:defRPr sz="1200">
+              <a:defRPr sz="1600">
                 <a:solidFill>
                   <a:srgbClr val="333333"/>
                 </a:solidFill>
@@ -4098,9 +4101,9 @@
           <a:p>
             <a:pPr lvl="1">
               <a:spcAft>
-                <a:spcPts val="600"/>
+                <a:spcPts val="800"/>
               </a:spcAft>
-              <a:defRPr sz="1200">
+              <a:defRPr sz="1600">
                 <a:solidFill>
                   <a:srgbClr val="333333"/>
                 </a:solidFill>
@@ -4113,9 +4116,9 @@
           <a:p>
             <a:pPr>
               <a:spcAft>
-                <a:spcPts val="600"/>
+                <a:spcPts val="800"/>
               </a:spcAft>
-              <a:defRPr sz="1400">
+              <a:defRPr sz="1800">
                 <a:solidFill>
                   <a:srgbClr val="333333"/>
                 </a:solidFill>
@@ -4125,9 +4128,9 @@
           <a:p>
             <a:pPr>
               <a:spcAft>
-                <a:spcPts val="600"/>
+                <a:spcPts val="800"/>
               </a:spcAft>
-              <a:defRPr sz="1400" b="1">
+              <a:defRPr sz="1800" b="1">
                 <a:solidFill>
                   <a:srgbClr val="5A2030"/>
                 </a:solidFill>
@@ -4140,9 +4143,9 @@
           <a:p>
             <a:pPr lvl="1">
               <a:spcAft>
-                <a:spcPts val="600"/>
+                <a:spcPts val="800"/>
               </a:spcAft>
-              <a:defRPr sz="1200">
+              <a:defRPr sz="1600">
                 <a:solidFill>
                   <a:srgbClr val="333333"/>
                 </a:solidFill>
@@ -4155,9 +4158,9 @@
           <a:p>
             <a:pPr lvl="1">
               <a:spcAft>
-                <a:spcPts val="600"/>
+                <a:spcPts val="800"/>
               </a:spcAft>
-              <a:defRPr sz="1200">
+              <a:defRPr sz="1600">
                 <a:solidFill>
                   <a:srgbClr val="333333"/>
                 </a:solidFill>
@@ -4170,9 +4173,9 @@
           <a:p>
             <a:pPr lvl="1">
               <a:spcAft>
-                <a:spcPts val="600"/>
+                <a:spcPts val="800"/>
               </a:spcAft>
-              <a:defRPr sz="1200">
+              <a:defRPr sz="1600">
                 <a:solidFill>
                   <a:srgbClr val="333333"/>
                 </a:solidFill>
@@ -4185,9 +4188,9 @@
           <a:p>
             <a:pPr>
               <a:spcAft>
-                <a:spcPts val="600"/>
+                <a:spcPts val="800"/>
               </a:spcAft>
-              <a:defRPr sz="1400">
+              <a:defRPr sz="1800">
                 <a:solidFill>
                   <a:srgbClr val="333333"/>
                 </a:solidFill>
@@ -4197,9 +4200,9 @@
           <a:p>
             <a:pPr>
               <a:spcAft>
-                <a:spcPts val="600"/>
+                <a:spcPts val="800"/>
               </a:spcAft>
-              <a:defRPr sz="1400" b="1">
+              <a:defRPr sz="1800" b="1">
                 <a:solidFill>
                   <a:srgbClr val="5A2030"/>
                 </a:solidFill>
@@ -4212,9 +4215,9 @@
           <a:p>
             <a:pPr lvl="1">
               <a:spcAft>
-                <a:spcPts val="600"/>
+                <a:spcPts val="800"/>
               </a:spcAft>
-              <a:defRPr sz="1200">
+              <a:defRPr sz="1600">
                 <a:solidFill>
                   <a:srgbClr val="333333"/>
                 </a:solidFill>
@@ -4227,9 +4230,9 @@
           <a:p>
             <a:pPr lvl="1">
               <a:spcAft>
-                <a:spcPts val="600"/>
+                <a:spcPts val="800"/>
               </a:spcAft>
-              <a:defRPr sz="1200">
+              <a:defRPr sz="1600">
                 <a:solidFill>
                   <a:srgbClr val="333333"/>
                 </a:solidFill>
@@ -4268,7 +4271,7 @@
         <p:spPr>
           <a:xfrm>
             <a:off x="0" y="0"/>
-            <a:ext cx="9144000" cy="914400"/>
+            <a:ext cx="12191695" cy="1005840"/>
           </a:xfrm>
           <a:prstGeom prst="rect">
             <a:avLst/>
@@ -4282,7 +4285,7 @@
           <a:lstStyle/>
           <a:p>
             <a:pPr>
-              <a:defRPr sz="2200" b="1">
+              <a:defRPr sz="2800" b="1">
                 <a:solidFill>
                   <a:srgbClr val="5A2030"/>
                 </a:solidFill>
@@ -4302,8 +4305,8 @@
         </p:nvSpPr>
         <p:spPr>
           <a:xfrm>
-            <a:off x="457200" y="868680"/>
-            <a:ext cx="8229600" cy="27432"/>
+            <a:off x="731520" y="960120"/>
+            <a:ext cx="10698480" cy="27432"/>
           </a:xfrm>
           <a:prstGeom prst="rect">
             <a:avLst/>
@@ -4346,8 +4349,8 @@
           <p:nvPr/>
         </p:nvGraphicFramePr>
         <p:xfrm>
-          <a:off x="457200" y="1188720"/>
-          <a:ext cx="8229600" cy="1828800"/>
+          <a:off x="731520" y="1280160"/>
+          <a:ext cx="10698480" cy="2286000"/>
         </p:xfrm>
         <a:graphic>
           <a:graphicData uri="http://schemas.openxmlformats.org/drawingml/2006/table">
@@ -4356,19 +4359,19 @@
                 <a:tableStyleId>{5C22544A-7EE6-4342-B048-85BDC9FD1C3A}</a:tableStyleId>
               </a:tblPr>
               <a:tblGrid>
-                <a:gridCol w="2057400"/>
-                <a:gridCol w="2057400"/>
-                <a:gridCol w="2057400"/>
-                <a:gridCol w="2057400"/>
+                <a:gridCol w="2674620"/>
+                <a:gridCol w="2674620"/>
+                <a:gridCol w="2674620"/>
+                <a:gridCol w="2674620"/>
               </a:tblGrid>
-              <a:tr h="365760">
+              <a:tr h="457200">
                 <a:tc>
                   <a:txBody>
                     <a:bodyPr/>
                     <a:lstStyle/>
                     <a:p>
                       <a:pPr>
-                        <a:defRPr sz="1100" b="1">
+                        <a:defRPr sz="1400" b="1">
                           <a:solidFill>
                             <a:srgbClr val="FFFFFF"/>
                           </a:solidFill>
@@ -4391,7 +4394,7 @@
                     <a:lstStyle/>
                     <a:p>
                       <a:pPr>
-                        <a:defRPr sz="1100" b="1">
+                        <a:defRPr sz="1400" b="1">
                           <a:solidFill>
                             <a:srgbClr val="FFFFFF"/>
                           </a:solidFill>
@@ -4414,7 +4417,7 @@
                     <a:lstStyle/>
                     <a:p>
                       <a:pPr>
-                        <a:defRPr sz="1100" b="1">
+                        <a:defRPr sz="1400" b="1">
                           <a:solidFill>
                             <a:srgbClr val="FFFFFF"/>
                           </a:solidFill>
@@ -4437,7 +4440,7 @@
                     <a:lstStyle/>
                     <a:p>
                       <a:pPr>
-                        <a:defRPr sz="1100" b="1">
+                        <a:defRPr sz="1400" b="1">
                           <a:solidFill>
                             <a:srgbClr val="FFFFFF"/>
                           </a:solidFill>
@@ -4455,14 +4458,14 @@
                   </a:tcPr>
                 </a:tc>
               </a:tr>
-              <a:tr h="365760">
+              <a:tr h="457200">
                 <a:tc>
                   <a:txBody>
                     <a:bodyPr/>
                     <a:lstStyle/>
                     <a:p>
                       <a:pPr>
-                        <a:defRPr sz="1000">
+                        <a:defRPr sz="1300">
                           <a:solidFill>
                             <a:srgbClr val="333333"/>
                           </a:solidFill>
@@ -4485,7 +4488,7 @@
                     <a:lstStyle/>
                     <a:p>
                       <a:pPr>
-                        <a:defRPr sz="1000">
+                        <a:defRPr sz="1300">
                           <a:solidFill>
                             <a:srgbClr val="333333"/>
                           </a:solidFill>
@@ -4508,7 +4511,7 @@
                     <a:lstStyle/>
                     <a:p>
                       <a:pPr>
-                        <a:defRPr sz="1000">
+                        <a:defRPr sz="1300">
                           <a:solidFill>
                             <a:srgbClr val="333333"/>
                           </a:solidFill>
@@ -4531,7 +4534,7 @@
                     <a:lstStyle/>
                     <a:p>
                       <a:pPr>
-                        <a:defRPr sz="1000">
+                        <a:defRPr sz="1300">
                           <a:solidFill>
                             <a:srgbClr val="333333"/>
                           </a:solidFill>
@@ -4549,14 +4552,14 @@
                   </a:tcPr>
                 </a:tc>
               </a:tr>
-              <a:tr h="365760">
+              <a:tr h="457200">
                 <a:tc>
                   <a:txBody>
                     <a:bodyPr/>
                     <a:lstStyle/>
                     <a:p>
                       <a:pPr>
-                        <a:defRPr sz="1000">
+                        <a:defRPr sz="1300">
                           <a:solidFill>
                             <a:srgbClr val="333333"/>
                           </a:solidFill>
@@ -4575,7 +4578,7 @@
                     <a:lstStyle/>
                     <a:p>
                       <a:pPr>
-                        <a:defRPr sz="1000">
+                        <a:defRPr sz="1300">
                           <a:solidFill>
                             <a:srgbClr val="333333"/>
                           </a:solidFill>
@@ -4594,7 +4597,7 @@
                     <a:lstStyle/>
                     <a:p>
                       <a:pPr>
-                        <a:defRPr sz="1000">
+                        <a:defRPr sz="1300">
                           <a:solidFill>
                             <a:srgbClr val="333333"/>
                           </a:solidFill>
@@ -4613,7 +4616,7 @@
                     <a:lstStyle/>
                     <a:p>
                       <a:pPr>
-                        <a:defRPr sz="1000">
+                        <a:defRPr sz="1300">
                           <a:solidFill>
                             <a:srgbClr val="333333"/>
                           </a:solidFill>
@@ -4627,14 +4630,14 @@
                   <a:tcPr/>
                 </a:tc>
               </a:tr>
-              <a:tr h="365760">
+              <a:tr h="457200">
                 <a:tc>
                   <a:txBody>
                     <a:bodyPr/>
                     <a:lstStyle/>
                     <a:p>
                       <a:pPr>
-                        <a:defRPr sz="1000">
+                        <a:defRPr sz="1300">
                           <a:solidFill>
                             <a:srgbClr val="333333"/>
                           </a:solidFill>
@@ -4657,7 +4660,7 @@
                     <a:lstStyle/>
                     <a:p>
                       <a:pPr>
-                        <a:defRPr sz="1000">
+                        <a:defRPr sz="1300">
                           <a:solidFill>
                             <a:srgbClr val="333333"/>
                           </a:solidFill>
@@ -4680,7 +4683,7 @@
                     <a:lstStyle/>
                     <a:p>
                       <a:pPr>
-                        <a:defRPr sz="1000">
+                        <a:defRPr sz="1300">
                           <a:solidFill>
                             <a:srgbClr val="333333"/>
                           </a:solidFill>
@@ -4703,7 +4706,7 @@
                     <a:lstStyle/>
                     <a:p>
                       <a:pPr>
-                        <a:defRPr sz="1000">
+                        <a:defRPr sz="1300">
                           <a:solidFill>
                             <a:srgbClr val="333333"/>
                           </a:solidFill>
@@ -4721,14 +4724,14 @@
                   </a:tcPr>
                 </a:tc>
               </a:tr>
-              <a:tr h="365760">
+              <a:tr h="457200">
                 <a:tc>
                   <a:txBody>
                     <a:bodyPr/>
                     <a:lstStyle/>
                     <a:p>
                       <a:pPr>
-                        <a:defRPr sz="1000">
+                        <a:defRPr sz="1300">
                           <a:solidFill>
                             <a:srgbClr val="333333"/>
                           </a:solidFill>
@@ -4747,7 +4750,7 @@
                     <a:lstStyle/>
                     <a:p>
                       <a:pPr>
-                        <a:defRPr sz="1000">
+                        <a:defRPr sz="1300">
                           <a:solidFill>
                             <a:srgbClr val="333333"/>
                           </a:solidFill>
@@ -4766,7 +4769,7 @@
                     <a:lstStyle/>
                     <a:p>
                       <a:pPr>
-                        <a:defRPr sz="1000">
+                        <a:defRPr sz="1300">
                           <a:solidFill>
                             <a:srgbClr val="333333"/>
                           </a:solidFill>
@@ -4785,7 +4788,7 @@
                     <a:lstStyle/>
                     <a:p>
                       <a:pPr>
-                        <a:defRPr sz="1000">
+                        <a:defRPr sz="1300">
                           <a:solidFill>
                             <a:srgbClr val="333333"/>
                           </a:solidFill>
@@ -4830,7 +4833,7 @@
         <p:spPr>
           <a:xfrm>
             <a:off x="0" y="0"/>
-            <a:ext cx="9144000" cy="914400"/>
+            <a:ext cx="12191695" cy="1005840"/>
           </a:xfrm>
           <a:prstGeom prst="rect">
             <a:avLst/>
@@ -4844,7 +4847,7 @@
           <a:lstStyle/>
           <a:p>
             <a:pPr>
-              <a:defRPr sz="2200" b="1">
+              <a:defRPr sz="2800" b="1">
                 <a:solidFill>
                   <a:srgbClr val="5A2030"/>
                 </a:solidFill>
@@ -4864,8 +4867,8 @@
         </p:nvSpPr>
         <p:spPr>
           <a:xfrm>
-            <a:off x="457200" y="868680"/>
-            <a:ext cx="8229600" cy="27432"/>
+            <a:off x="731520" y="960120"/>
+            <a:ext cx="10698480" cy="27432"/>
           </a:xfrm>
           <a:prstGeom prst="rect">
             <a:avLst/>
@@ -4908,8 +4911,8 @@
           <p:nvPr/>
         </p:nvGraphicFramePr>
         <p:xfrm>
-          <a:off x="457200" y="1188720"/>
-          <a:ext cx="8229600" cy="1097280"/>
+          <a:off x="731520" y="1280160"/>
+          <a:ext cx="10698480" cy="1371600"/>
         </p:xfrm>
         <a:graphic>
           <a:graphicData uri="http://schemas.openxmlformats.org/drawingml/2006/table">
@@ -4918,19 +4921,19 @@
                 <a:tableStyleId>{5C22544A-7EE6-4342-B048-85BDC9FD1C3A}</a:tableStyleId>
               </a:tblPr>
               <a:tblGrid>
-                <a:gridCol w="2057400"/>
-                <a:gridCol w="2057400"/>
-                <a:gridCol w="2057400"/>
-                <a:gridCol w="2057400"/>
+                <a:gridCol w="2674620"/>
+                <a:gridCol w="2674620"/>
+                <a:gridCol w="2674620"/>
+                <a:gridCol w="2674620"/>
               </a:tblGrid>
-              <a:tr h="365760">
+              <a:tr h="457200">
                 <a:tc>
                   <a:txBody>
                     <a:bodyPr/>
                     <a:lstStyle/>
                     <a:p>
                       <a:pPr>
-                        <a:defRPr sz="1100" b="1">
+                        <a:defRPr sz="1400" b="1">
                           <a:solidFill>
                             <a:srgbClr val="FFFFFF"/>
                           </a:solidFill>
@@ -4953,7 +4956,7 @@
                     <a:lstStyle/>
                     <a:p>
                       <a:pPr>
-                        <a:defRPr sz="1100" b="1">
+                        <a:defRPr sz="1400" b="1">
                           <a:solidFill>
                             <a:srgbClr val="FFFFFF"/>
                           </a:solidFill>
@@ -4976,7 +4979,7 @@
                     <a:lstStyle/>
                     <a:p>
                       <a:pPr>
-                        <a:defRPr sz="1100" b="1">
+                        <a:defRPr sz="1400" b="1">
                           <a:solidFill>
                             <a:srgbClr val="FFFFFF"/>
                           </a:solidFill>
@@ -4999,7 +5002,7 @@
                     <a:lstStyle/>
                     <a:p>
                       <a:pPr>
-                        <a:defRPr sz="1100" b="1">
+                        <a:defRPr sz="1400" b="1">
                           <a:solidFill>
                             <a:srgbClr val="FFFFFF"/>
                           </a:solidFill>
@@ -5017,14 +5020,14 @@
                   </a:tcPr>
                 </a:tc>
               </a:tr>
-              <a:tr h="365760">
+              <a:tr h="457200">
                 <a:tc>
                   <a:txBody>
                     <a:bodyPr/>
                     <a:lstStyle/>
                     <a:p>
                       <a:pPr>
-                        <a:defRPr sz="1000">
+                        <a:defRPr sz="1300">
                           <a:solidFill>
                             <a:srgbClr val="333333"/>
                           </a:solidFill>
@@ -5047,7 +5050,7 @@
                     <a:lstStyle/>
                     <a:p>
                       <a:pPr>
-                        <a:defRPr sz="1000">
+                        <a:defRPr sz="1300">
                           <a:solidFill>
                             <a:srgbClr val="333333"/>
                           </a:solidFill>
@@ -5070,7 +5073,7 @@
                     <a:lstStyle/>
                     <a:p>
                       <a:pPr>
-                        <a:defRPr sz="1000">
+                        <a:defRPr sz="1300">
                           <a:solidFill>
                             <a:srgbClr val="333333"/>
                           </a:solidFill>
@@ -5093,7 +5096,7 @@
                     <a:lstStyle/>
                     <a:p>
                       <a:pPr>
-                        <a:defRPr sz="1000">
+                        <a:defRPr sz="1300">
                           <a:solidFill>
                             <a:srgbClr val="333333"/>
                           </a:solidFill>
@@ -5111,14 +5114,14 @@
                   </a:tcPr>
                 </a:tc>
               </a:tr>
-              <a:tr h="365760">
+              <a:tr h="457200">
                 <a:tc>
                   <a:txBody>
                     <a:bodyPr/>
                     <a:lstStyle/>
                     <a:p>
                       <a:pPr>
-                        <a:defRPr sz="1000">
+                        <a:defRPr sz="1300">
                           <a:solidFill>
                             <a:srgbClr val="333333"/>
                           </a:solidFill>
@@ -5137,7 +5140,7 @@
                     <a:lstStyle/>
                     <a:p>
                       <a:pPr>
-                        <a:defRPr sz="1000">
+                        <a:defRPr sz="1300">
                           <a:solidFill>
                             <a:srgbClr val="333333"/>
                           </a:solidFill>
@@ -5156,7 +5159,7 @@
                     <a:lstStyle/>
                     <a:p>
                       <a:pPr>
-                        <a:defRPr sz="1000">
+                        <a:defRPr sz="1300">
                           <a:solidFill>
                             <a:srgbClr val="333333"/>
                           </a:solidFill>
@@ -5175,7 +5178,7 @@
                     <a:lstStyle/>
                     <a:p>
                       <a:pPr>
-                        <a:defRPr sz="1000">
+                        <a:defRPr sz="1300">
                           <a:solidFill>
                             <a:srgbClr val="333333"/>
                           </a:solidFill>
@@ -5201,8 +5204,8 @@
         </p:nvSpPr>
         <p:spPr>
           <a:xfrm>
-            <a:off x="548640" y="3200400"/>
-            <a:ext cx="8046720" cy="1371600"/>
+            <a:off x="914400" y="3657600"/>
+            <a:ext cx="10332720" cy="1371600"/>
           </a:xfrm>
           <a:prstGeom prst="rect">
             <a:avLst/>
@@ -5217,9 +5220,9 @@
           <a:p>
             <a:pPr>
               <a:spcAft>
-                <a:spcPts val="800"/>
+                <a:spcPts val="1000"/>
               </a:spcAft>
-              <a:defRPr sz="1300" b="1">
+              <a:defRPr sz="1800" b="1">
                 <a:solidFill>
                   <a:srgbClr val="5A2030"/>
                 </a:solidFill>
@@ -5232,9 +5235,9 @@
           <a:p>
             <a:pPr>
               <a:spcAft>
-                <a:spcPts val="800"/>
+                <a:spcPts val="1000"/>
               </a:spcAft>
-              <a:defRPr sz="1300" b="1">
+              <a:defRPr sz="1800" b="1">
                 <a:solidFill>
                   <a:srgbClr val="5A2030"/>
                 </a:solidFill>
@@ -5273,7 +5276,7 @@
         <p:spPr>
           <a:xfrm>
             <a:off x="0" y="0"/>
-            <a:ext cx="9144000" cy="914400"/>
+            <a:ext cx="12191695" cy="1005840"/>
           </a:xfrm>
           <a:prstGeom prst="rect">
             <a:avLst/>
@@ -5287,7 +5290,7 @@
           <a:lstStyle/>
           <a:p>
             <a:pPr>
-              <a:defRPr sz="2200" b="1">
+              <a:defRPr sz="2800" b="1">
                 <a:solidFill>
                   <a:srgbClr val="5A2030"/>
                 </a:solidFill>
@@ -5307,8 +5310,8 @@
         </p:nvSpPr>
         <p:spPr>
           <a:xfrm>
-            <a:off x="457200" y="868680"/>
-            <a:ext cx="8229600" cy="27432"/>
+            <a:off x="731520" y="960120"/>
+            <a:ext cx="10698480" cy="27432"/>
           </a:xfrm>
           <a:prstGeom prst="rect">
             <a:avLst/>
@@ -5351,8 +5354,8 @@
           <p:nvPr/>
         </p:nvGraphicFramePr>
         <p:xfrm>
-          <a:off x="457200" y="1188720"/>
-          <a:ext cx="8229600" cy="2560320"/>
+          <a:off x="731520" y="1280160"/>
+          <a:ext cx="10698480" cy="3200400"/>
         </p:xfrm>
         <a:graphic>
           <a:graphicData uri="http://schemas.openxmlformats.org/drawingml/2006/table">
@@ -5361,20 +5364,20 @@
                 <a:tableStyleId>{5C22544A-7EE6-4342-B048-85BDC9FD1C3A}</a:tableStyleId>
               </a:tblPr>
               <a:tblGrid>
-                <a:gridCol w="1645920"/>
-                <a:gridCol w="1645920"/>
-                <a:gridCol w="1645920"/>
-                <a:gridCol w="1645920"/>
-                <a:gridCol w="1645920"/>
+                <a:gridCol w="2139696"/>
+                <a:gridCol w="2139696"/>
+                <a:gridCol w="2139696"/>
+                <a:gridCol w="2139696"/>
+                <a:gridCol w="2139696"/>
               </a:tblGrid>
-              <a:tr h="365760">
+              <a:tr h="457200">
                 <a:tc>
                   <a:txBody>
                     <a:bodyPr/>
                     <a:lstStyle/>
                     <a:p>
                       <a:pPr>
-                        <a:defRPr sz="1100" b="1">
+                        <a:defRPr sz="1400" b="1">
                           <a:solidFill>
                             <a:srgbClr val="FFFFFF"/>
                           </a:solidFill>
@@ -5394,7 +5397,7 @@
                     <a:lstStyle/>
                     <a:p>
                       <a:pPr>
-                        <a:defRPr sz="1100" b="1">
+                        <a:defRPr sz="1400" b="1">
                           <a:solidFill>
                             <a:srgbClr val="FFFFFF"/>
                           </a:solidFill>
@@ -5417,7 +5420,7 @@
                     <a:lstStyle/>
                     <a:p>
                       <a:pPr>
-                        <a:defRPr sz="1100" b="1">
+                        <a:defRPr sz="1400" b="1">
                           <a:solidFill>
                             <a:srgbClr val="FFFFFF"/>
                           </a:solidFill>
@@ -5440,7 +5443,7 @@
                     <a:lstStyle/>
                     <a:p>
                       <a:pPr>
-                        <a:defRPr sz="1100" b="1">
+                        <a:defRPr sz="1400" b="1">
                           <a:solidFill>
                             <a:srgbClr val="FFFFFF"/>
                           </a:solidFill>
@@ -5463,7 +5466,7 @@
                     <a:lstStyle/>
                     <a:p>
                       <a:pPr>
-                        <a:defRPr sz="1100" b="1">
+                        <a:defRPr sz="1400" b="1">
                           <a:solidFill>
                             <a:srgbClr val="FFFFFF"/>
                           </a:solidFill>
@@ -5481,14 +5484,14 @@
                   </a:tcPr>
                 </a:tc>
               </a:tr>
-              <a:tr h="365760">
+              <a:tr h="457200">
                 <a:tc>
                   <a:txBody>
                     <a:bodyPr/>
                     <a:lstStyle/>
                     <a:p>
                       <a:pPr>
-                        <a:defRPr sz="1000">
+                        <a:defRPr sz="1300">
                           <a:solidFill>
                             <a:srgbClr val="333333"/>
                           </a:solidFill>
@@ -5511,7 +5514,7 @@
                     <a:lstStyle/>
                     <a:p>
                       <a:pPr>
-                        <a:defRPr sz="1000">
+                        <a:defRPr sz="1300">
                           <a:solidFill>
                             <a:srgbClr val="333333"/>
                           </a:solidFill>
@@ -5534,7 +5537,7 @@
                     <a:lstStyle/>
                     <a:p>
                       <a:pPr>
-                        <a:defRPr sz="1000">
+                        <a:defRPr sz="1300">
                           <a:solidFill>
                             <a:srgbClr val="333333"/>
                           </a:solidFill>
@@ -5557,7 +5560,7 @@
                     <a:lstStyle/>
                     <a:p>
                       <a:pPr>
-                        <a:defRPr sz="1000">
+                        <a:defRPr sz="1300">
                           <a:solidFill>
                             <a:srgbClr val="333333"/>
                           </a:solidFill>
@@ -5580,7 +5583,7 @@
                     <a:lstStyle/>
                     <a:p>
                       <a:pPr>
-                        <a:defRPr sz="1000">
+                        <a:defRPr sz="1300">
                           <a:solidFill>
                             <a:srgbClr val="333333"/>
                           </a:solidFill>
@@ -5598,14 +5601,14 @@
                   </a:tcPr>
                 </a:tc>
               </a:tr>
-              <a:tr h="365760">
+              <a:tr h="457200">
                 <a:tc>
                   <a:txBody>
                     <a:bodyPr/>
                     <a:lstStyle/>
                     <a:p>
                       <a:pPr>
-                        <a:defRPr sz="1000">
+                        <a:defRPr sz="1300">
                           <a:solidFill>
                             <a:srgbClr val="333333"/>
                           </a:solidFill>
@@ -5624,7 +5627,7 @@
                     <a:lstStyle/>
                     <a:p>
                       <a:pPr>
-                        <a:defRPr sz="1000">
+                        <a:defRPr sz="1300">
                           <a:solidFill>
                             <a:srgbClr val="333333"/>
                           </a:solidFill>
@@ -5643,7 +5646,7 @@
                     <a:lstStyle/>
                     <a:p>
                       <a:pPr>
-                        <a:defRPr sz="1000">
+                        <a:defRPr sz="1300">
                           <a:solidFill>
                             <a:srgbClr val="333333"/>
                           </a:solidFill>
@@ -5662,7 +5665,7 @@
                     <a:lstStyle/>
                     <a:p>
                       <a:pPr>
-                        <a:defRPr sz="1000">
+                        <a:defRPr sz="1300">
                           <a:solidFill>
                             <a:srgbClr val="333333"/>
                           </a:solidFill>
@@ -5681,7 +5684,7 @@
                     <a:lstStyle/>
                     <a:p>
                       <a:pPr>
-                        <a:defRPr sz="1000">
+                        <a:defRPr sz="1300">
                           <a:solidFill>
                             <a:srgbClr val="333333"/>
                           </a:solidFill>
@@ -5695,14 +5698,14 @@
                   <a:tcPr/>
                 </a:tc>
               </a:tr>
-              <a:tr h="365760">
+              <a:tr h="457200">
                 <a:tc>
                   <a:txBody>
                     <a:bodyPr/>
                     <a:lstStyle/>
                     <a:p>
                       <a:pPr>
-                        <a:defRPr sz="1000">
+                        <a:defRPr sz="1300">
                           <a:solidFill>
                             <a:srgbClr val="333333"/>
                           </a:solidFill>
@@ -5725,7 +5728,7 @@
                     <a:lstStyle/>
                     <a:p>
                       <a:pPr>
-                        <a:defRPr sz="1000">
+                        <a:defRPr sz="1300">
                           <a:solidFill>
                             <a:srgbClr val="333333"/>
                           </a:solidFill>
@@ -5748,7 +5751,7 @@
                     <a:lstStyle/>
                     <a:p>
                       <a:pPr>
-                        <a:defRPr sz="1000">
+                        <a:defRPr sz="1300">
                           <a:solidFill>
                             <a:srgbClr val="333333"/>
                           </a:solidFill>
@@ -5771,7 +5774,7 @@
                     <a:lstStyle/>
                     <a:p>
                       <a:pPr>
-                        <a:defRPr sz="1000">
+                        <a:defRPr sz="1300">
                           <a:solidFill>
                             <a:srgbClr val="333333"/>
                           </a:solidFill>
@@ -5794,7 +5797,7 @@
                     <a:lstStyle/>
                     <a:p>
                       <a:pPr>
-                        <a:defRPr sz="1000">
+                        <a:defRPr sz="1300">
                           <a:solidFill>
                             <a:srgbClr val="333333"/>
                           </a:solidFill>
@@ -5812,14 +5815,14 @@
                   </a:tcPr>
                 </a:tc>
               </a:tr>
-              <a:tr h="365760">
+              <a:tr h="457200">
                 <a:tc>
                   <a:txBody>
                     <a:bodyPr/>
                     <a:lstStyle/>
                     <a:p>
                       <a:pPr>
-                        <a:defRPr sz="1000">
+                        <a:defRPr sz="1300">
                           <a:solidFill>
                             <a:srgbClr val="333333"/>
                           </a:solidFill>
@@ -5838,7 +5841,7 @@
                     <a:lstStyle/>
                     <a:p>
                       <a:pPr>
-                        <a:defRPr sz="1000">
+                        <a:defRPr sz="1300">
                           <a:solidFill>
                             <a:srgbClr val="333333"/>
                           </a:solidFill>
@@ -5857,7 +5860,7 @@
                     <a:lstStyle/>
                     <a:p>
                       <a:pPr>
-                        <a:defRPr sz="1000">
+                        <a:defRPr sz="1300">
                           <a:solidFill>
                             <a:srgbClr val="333333"/>
                           </a:solidFill>
@@ -5876,7 +5879,7 @@
                     <a:lstStyle/>
                     <a:p>
                       <a:pPr>
-                        <a:defRPr sz="1000">
+                        <a:defRPr sz="1300">
                           <a:solidFill>
                             <a:srgbClr val="333333"/>
                           </a:solidFill>
@@ -5895,7 +5898,7 @@
                     <a:lstStyle/>
                     <a:p>
                       <a:pPr>
-                        <a:defRPr sz="1000">
+                        <a:defRPr sz="1300">
                           <a:solidFill>
                             <a:srgbClr val="333333"/>
                           </a:solidFill>
@@ -5909,14 +5912,14 @@
                   <a:tcPr/>
                 </a:tc>
               </a:tr>
-              <a:tr h="365760">
+              <a:tr h="457200">
                 <a:tc>
                   <a:txBody>
                     <a:bodyPr/>
                     <a:lstStyle/>
                     <a:p>
                       <a:pPr>
-                        <a:defRPr sz="1000">
+                        <a:defRPr sz="1300">
                           <a:solidFill>
                             <a:srgbClr val="333333"/>
                           </a:solidFill>
@@ -5939,7 +5942,7 @@
                     <a:lstStyle/>
                     <a:p>
                       <a:pPr>
-                        <a:defRPr sz="1000">
+                        <a:defRPr sz="1300">
                           <a:solidFill>
                             <a:srgbClr val="333333"/>
                           </a:solidFill>
@@ -5962,7 +5965,7 @@
                     <a:lstStyle/>
                     <a:p>
                       <a:pPr>
-                        <a:defRPr sz="1000">
+                        <a:defRPr sz="1300">
                           <a:solidFill>
                             <a:srgbClr val="333333"/>
                           </a:solidFill>
@@ -5985,7 +5988,7 @@
                     <a:lstStyle/>
                     <a:p>
                       <a:pPr>
-                        <a:defRPr sz="1000">
+                        <a:defRPr sz="1300">
                           <a:solidFill>
                             <a:srgbClr val="333333"/>
                           </a:solidFill>
@@ -6008,7 +6011,7 @@
                     <a:lstStyle/>
                     <a:p>
                       <a:pPr>
-                        <a:defRPr sz="1000">
+                        <a:defRPr sz="1300">
                           <a:solidFill>
                             <a:srgbClr val="333333"/>
                           </a:solidFill>
@@ -6026,14 +6029,14 @@
                   </a:tcPr>
                 </a:tc>
               </a:tr>
-              <a:tr h="365760">
+              <a:tr h="457200">
                 <a:tc>
                   <a:txBody>
                     <a:bodyPr/>
                     <a:lstStyle/>
                     <a:p>
                       <a:pPr>
-                        <a:defRPr sz="1000">
+                        <a:defRPr sz="1300">
                           <a:solidFill>
                             <a:srgbClr val="333333"/>
                           </a:solidFill>
@@ -6052,7 +6055,7 @@
                     <a:lstStyle/>
                     <a:p>
                       <a:pPr>
-                        <a:defRPr sz="1000">
+                        <a:defRPr sz="1300">
                           <a:solidFill>
                             <a:srgbClr val="333333"/>
                           </a:solidFill>
@@ -6071,7 +6074,7 @@
                     <a:lstStyle/>
                     <a:p>
                       <a:pPr>
-                        <a:defRPr sz="1000">
+                        <a:defRPr sz="1300">
                           <a:solidFill>
                             <a:srgbClr val="333333"/>
                           </a:solidFill>
@@ -6090,7 +6093,7 @@
                     <a:lstStyle/>
                     <a:p>
                       <a:pPr>
-                        <a:defRPr sz="1000">
+                        <a:defRPr sz="1300">
                           <a:solidFill>
                             <a:srgbClr val="333333"/>
                           </a:solidFill>
@@ -6109,7 +6112,7 @@
                     <a:lstStyle/>
                     <a:p>
                       <a:pPr>
-                        <a:defRPr sz="1000">
+                        <a:defRPr sz="1300">
                           <a:solidFill>
                             <a:srgbClr val="333333"/>
                           </a:solidFill>
@@ -6154,7 +6157,7 @@
         <p:spPr>
           <a:xfrm>
             <a:off x="0" y="0"/>
-            <a:ext cx="9144000" cy="914400"/>
+            <a:ext cx="12191695" cy="1005840"/>
           </a:xfrm>
           <a:prstGeom prst="rect">
             <a:avLst/>
@@ -6168,7 +6171,7 @@
           <a:lstStyle/>
           <a:p>
             <a:pPr algn="l">
-              <a:defRPr sz="2200" b="1">
+              <a:defRPr sz="2800" b="1">
                 <a:solidFill>
                   <a:srgbClr val="5A2030"/>
                 </a:solidFill>
@@ -6188,8 +6191,8 @@
         </p:nvSpPr>
         <p:spPr>
           <a:xfrm>
-            <a:off x="457200" y="868680"/>
-            <a:ext cx="8229600" cy="27432"/>
+            <a:off x="731520" y="960120"/>
+            <a:ext cx="10698480" cy="27432"/>
           </a:xfrm>
           <a:prstGeom prst="rect">
             <a:avLst/>
@@ -6231,8 +6234,8 @@
         </p:nvSpPr>
         <p:spPr>
           <a:xfrm>
-            <a:off x="548640" y="1097280"/>
-            <a:ext cx="8046720" cy="5029200"/>
+            <a:off x="914400" y="1280160"/>
+            <a:ext cx="10332720" cy="5029200"/>
           </a:xfrm>
           <a:prstGeom prst="rect">
             <a:avLst/>
@@ -6247,9 +6250,9 @@
           <a:p>
             <a:pPr>
               <a:spcAft>
-                <a:spcPts val="600"/>
+                <a:spcPts val="800"/>
               </a:spcAft>
-              <a:defRPr sz="1400" b="1">
+              <a:defRPr sz="1800" b="1">
                 <a:solidFill>
                   <a:srgbClr val="5A2030"/>
                 </a:solidFill>
@@ -6262,9 +6265,9 @@
           <a:p>
             <a:pPr>
               <a:spcAft>
-                <a:spcPts val="600"/>
+                <a:spcPts val="800"/>
               </a:spcAft>
-              <a:defRPr sz="1400">
+              <a:defRPr sz="1800">
                 <a:solidFill>
                   <a:srgbClr val="333333"/>
                 </a:solidFill>
@@ -6274,9 +6277,9 @@
           <a:p>
             <a:pPr>
               <a:spcAft>
-                <a:spcPts val="600"/>
+                <a:spcPts val="800"/>
               </a:spcAft>
-              <a:defRPr sz="1400">
+              <a:defRPr sz="1800">
                 <a:solidFill>
                   <a:srgbClr val="333333"/>
                 </a:solidFill>
@@ -6289,9 +6292,9 @@
           <a:p>
             <a:pPr>
               <a:spcAft>
-                <a:spcPts val="600"/>
+                <a:spcPts val="800"/>
               </a:spcAft>
-              <a:defRPr sz="1400">
+              <a:defRPr sz="1800">
                 <a:solidFill>
                   <a:srgbClr val="333333"/>
                 </a:solidFill>
@@ -6304,9 +6307,9 @@
           <a:p>
             <a:pPr>
               <a:spcAft>
-                <a:spcPts val="600"/>
+                <a:spcPts val="800"/>
               </a:spcAft>
-              <a:defRPr sz="1400">
+              <a:defRPr sz="1800">
                 <a:solidFill>
                   <a:srgbClr val="333333"/>
                 </a:solidFill>
@@ -6319,9 +6322,9 @@
           <a:p>
             <a:pPr>
               <a:spcAft>
-                <a:spcPts val="600"/>
+                <a:spcPts val="800"/>
               </a:spcAft>
-              <a:defRPr sz="1400">
+              <a:defRPr sz="1800">
                 <a:solidFill>
                   <a:srgbClr val="333333"/>
                 </a:solidFill>
@@ -6334,9 +6337,9 @@
           <a:p>
             <a:pPr>
               <a:spcAft>
-                <a:spcPts val="600"/>
+                <a:spcPts val="800"/>
               </a:spcAft>
-              <a:defRPr sz="1400">
+              <a:defRPr sz="1800">
                 <a:solidFill>
                   <a:srgbClr val="333333"/>
                 </a:solidFill>
@@ -6349,9 +6352,9 @@
           <a:p>
             <a:pPr>
               <a:spcAft>
-                <a:spcPts val="600"/>
+                <a:spcPts val="800"/>
               </a:spcAft>
-              <a:defRPr sz="1400">
+              <a:defRPr sz="1800">
                 <a:solidFill>
                   <a:srgbClr val="333333"/>
                 </a:solidFill>
@@ -6361,9 +6364,9 @@
           <a:p>
             <a:pPr>
               <a:spcAft>
-                <a:spcPts val="600"/>
+                <a:spcPts val="800"/>
               </a:spcAft>
-              <a:defRPr sz="1400" b="1">
+              <a:defRPr sz="1800" b="1">
                 <a:solidFill>
                   <a:srgbClr val="5A2030"/>
                 </a:solidFill>
@@ -6376,9 +6379,9 @@
           <a:p>
             <a:pPr lvl="1">
               <a:spcAft>
-                <a:spcPts val="600"/>
+                <a:spcPts val="800"/>
               </a:spcAft>
-              <a:defRPr sz="1200">
+              <a:defRPr sz="1600">
                 <a:solidFill>
                   <a:srgbClr val="333333"/>
                 </a:solidFill>
@@ -6417,7 +6420,7 @@
         <p:spPr>
           <a:xfrm>
             <a:off x="0" y="0"/>
-            <a:ext cx="9144000" cy="914400"/>
+            <a:ext cx="12191695" cy="1005840"/>
           </a:xfrm>
           <a:prstGeom prst="rect">
             <a:avLst/>
@@ -6431,7 +6434,7 @@
           <a:lstStyle/>
           <a:p>
             <a:pPr algn="l">
-              <a:defRPr sz="2200" b="1">
+              <a:defRPr sz="2800" b="1">
                 <a:solidFill>
                   <a:srgbClr val="5A2030"/>
                 </a:solidFill>
@@ -6451,8 +6454,8 @@
         </p:nvSpPr>
         <p:spPr>
           <a:xfrm>
-            <a:off x="457200" y="868680"/>
-            <a:ext cx="8229600" cy="27432"/>
+            <a:off x="731520" y="960120"/>
+            <a:ext cx="10698480" cy="27432"/>
           </a:xfrm>
           <a:prstGeom prst="rect">
             <a:avLst/>
@@ -6494,8 +6497,8 @@
         </p:nvSpPr>
         <p:spPr>
           <a:xfrm>
-            <a:off x="548640" y="1097280"/>
-            <a:ext cx="8046720" cy="5029200"/>
+            <a:off x="914400" y="1280160"/>
+            <a:ext cx="10332720" cy="5029200"/>
           </a:xfrm>
           <a:prstGeom prst="rect">
             <a:avLst/>
@@ -6510,9 +6513,9 @@
           <a:p>
             <a:pPr>
               <a:spcAft>
-                <a:spcPts val="600"/>
+                <a:spcPts val="800"/>
               </a:spcAft>
-              <a:defRPr sz="1400" b="1">
+              <a:defRPr sz="1800" b="1">
                 <a:solidFill>
                   <a:srgbClr val="5A2030"/>
                 </a:solidFill>
@@ -6525,9 +6528,9 @@
           <a:p>
             <a:pPr lvl="1">
               <a:spcAft>
-                <a:spcPts val="600"/>
+                <a:spcPts val="800"/>
               </a:spcAft>
-              <a:defRPr sz="1200">
+              <a:defRPr sz="1600">
                 <a:solidFill>
                   <a:srgbClr val="333333"/>
                 </a:solidFill>
@@ -6540,9 +6543,9 @@
           <a:p>
             <a:pPr>
               <a:spcAft>
-                <a:spcPts val="600"/>
+                <a:spcPts val="800"/>
               </a:spcAft>
-              <a:defRPr sz="1400">
+              <a:defRPr sz="1800">
                 <a:solidFill>
                   <a:srgbClr val="333333"/>
                 </a:solidFill>
@@ -6552,9 +6555,9 @@
           <a:p>
             <a:pPr>
               <a:spcAft>
-                <a:spcPts val="600"/>
+                <a:spcPts val="800"/>
               </a:spcAft>
-              <a:defRPr sz="1400" b="1">
+              <a:defRPr sz="1800" b="1">
                 <a:solidFill>
                   <a:srgbClr val="5A2030"/>
                 </a:solidFill>
@@ -6567,9 +6570,9 @@
           <a:p>
             <a:pPr lvl="1">
               <a:spcAft>
-                <a:spcPts val="600"/>
+                <a:spcPts val="800"/>
               </a:spcAft>
-              <a:defRPr sz="1200">
+              <a:defRPr sz="1600">
                 <a:solidFill>
                   <a:srgbClr val="333333"/>
                 </a:solidFill>
@@ -6582,9 +6585,9 @@
           <a:p>
             <a:pPr>
               <a:spcAft>
-                <a:spcPts val="600"/>
+                <a:spcPts val="800"/>
               </a:spcAft>
-              <a:defRPr sz="1400">
+              <a:defRPr sz="1800">
                 <a:solidFill>
                   <a:srgbClr val="333333"/>
                 </a:solidFill>
@@ -6594,9 +6597,9 @@
           <a:p>
             <a:pPr>
               <a:spcAft>
-                <a:spcPts val="600"/>
+                <a:spcPts val="800"/>
               </a:spcAft>
-              <a:defRPr sz="1400" b="1">
+              <a:defRPr sz="1800" b="1">
                 <a:solidFill>
                   <a:srgbClr val="5A2030"/>
                 </a:solidFill>
@@ -6609,9 +6612,9 @@
           <a:p>
             <a:pPr lvl="1">
               <a:spcAft>
-                <a:spcPts val="600"/>
+                <a:spcPts val="800"/>
               </a:spcAft>
-              <a:defRPr sz="1200">
+              <a:defRPr sz="1600">
                 <a:solidFill>
                   <a:srgbClr val="333333"/>
                 </a:solidFill>
@@ -6624,9 +6627,9 @@
           <a:p>
             <a:pPr>
               <a:spcAft>
-                <a:spcPts val="600"/>
+                <a:spcPts val="800"/>
               </a:spcAft>
-              <a:defRPr sz="1400">
+              <a:defRPr sz="1800">
                 <a:solidFill>
                   <a:srgbClr val="333333"/>
                 </a:solidFill>
@@ -6636,9 +6639,9 @@
           <a:p>
             <a:pPr>
               <a:spcAft>
-                <a:spcPts val="600"/>
+                <a:spcPts val="800"/>
               </a:spcAft>
-              <a:defRPr sz="1400" b="1">
+              <a:defRPr sz="1800" b="1">
                 <a:solidFill>
                   <a:srgbClr val="5A2030"/>
                 </a:solidFill>
@@ -6651,9 +6654,9 @@
           <a:p>
             <a:pPr lvl="1">
               <a:spcAft>
-                <a:spcPts val="600"/>
+                <a:spcPts val="800"/>
               </a:spcAft>
-              <a:defRPr sz="1200">
+              <a:defRPr sz="1600">
                 <a:solidFill>
                   <a:srgbClr val="333333"/>
                 </a:solidFill>
@@ -6666,7 +6669,7 @@
           <a:p/>
           <a:p>
             <a:pPr>
-              <a:defRPr sz="1100" i="1">
+              <a:defRPr sz="1400" i="1">
                 <a:solidFill>
                   <a:srgbClr val="888888"/>
                 </a:solidFill>

</xml_diff>